<commit_message>
Revise presentation: restructure narrative around civic democracy arc (measurement -> accountability -> reform)
</commit_message>
<xml_diff>
--- a/presentation/akashic_civics_presentation.pptx
+++ b/presentation/akashic_civics_presentation.pptx
@@ -23,9 +23,6 @@
     <p:sldId id="271" r:id="rId22"/>
     <p:sldId id="272" r:id="rId23"/>
     <p:sldId id="273" r:id="rId24"/>
-    <p:sldId id="274" r:id="rId25"/>
-    <p:sldId id="275" r:id="rId26"/>
-    <p:sldId id="276" r:id="rId27"/>
   </p:sldIdLst>
   <p:sldSz cx="9144000" cy="6858000" type="screen4x3"/>
   <p:notesSz cx="6858000" cy="9144000"/>
@@ -3124,7 +3121,7 @@
           <a:lstStyle/>
           <a:p>
             <a:r>
-              <a:t>Akashic Civics: Open-Source Tools for Criminal Justice Disparity Analysis &amp; Civic Democracy</a:t>
+              <a:t>Akashic Civics: From Invisible Injustice to Measurable Democracy</a:t>
             </a:r>
           </a:p>
         </p:txBody>
@@ -3184,7 +3181,7 @@
           <a:lstStyle/>
           <a:p>
             <a:r>
-              <a:t>Streaming Analysis (E23)</a:t>
+              <a:t>E21: Extension System -- Communities Add Their Own Power</a:t>
             </a:r>
           </a:p>
         </p:txBody>
@@ -3206,26 +3203,42 @@
           <a:p/>
           <a:p>
             <a:pPr>
-              <a:defRPr sz="1800"/>
-            </a:pPr>
-            <a:r>
-              <a:t>StreamProcessor reads JSONL in chunks, never loads full dataset</a:t>
-            </a:r>
-          </a:p>
-          <a:p>
-            <a:pPr>
-              <a:defRPr sz="1800"/>
-            </a:pPr>
-            <a:r>
-              <a:t>Incremental group statistics + disparity alerts</a:t>
-            </a:r>
-          </a:p>
-          <a:p>
-            <a:pPr>
-              <a:defRPr sz="1800"/>
-            </a:pPr>
-            <a:r>
-              <a:t>Implementation choice: Bounded chunks + persistent manifest for resume and scalability</a:t>
+              <a:defRPr sz="1600"/>
+            </a:pPr>
+            <a:r>
+              <a:t>Needs differ</a:t>
+            </a:r>
+          </a:p>
+          <a:p>
+            <a:pPr>
+              <a:defRPr sz="1600"/>
+            </a:pPr>
+            <a:r>
+              <a:t>A Native American tribal court needs different data sources than an urban DA's office</a:t>
+            </a:r>
+          </a:p>
+          <a:p>
+            <a:pPr>
+              <a:defRPr sz="1600"/>
+            </a:pPr>
+            <a:r>
+              <a:t>ExtensionRegistry lets communities ship custom plugins for DataSources, Analyses, and Exports</a:t>
+            </a:r>
+          </a:p>
+          <a:p>
+            <a:pPr>
+              <a:defRPr sz="1600"/>
+            </a:pPr>
+            <a:r>
+              <a:t>FOR DEMOCRACY: Tools adapt to local contexts instead of requiring local coding skills</a:t>
+            </a:r>
+          </a:p>
+          <a:p>
+            <a:pPr>
+              <a:defRPr sz="1600"/>
+            </a:pPr>
+            <a:r>
+              <a:t>Community ownership starts with modular architecture</a:t>
             </a:r>
           </a:p>
         </p:txBody>
@@ -3264,7 +3277,7 @@
           <a:lstStyle/>
           <a:p>
             <a:r>
-              <a:t>Dashboard + API (E24)</a:t>
+              <a:t>E22: R Package -- Speaking Policy's Language</a:t>
             </a:r>
           </a:p>
         </p:txBody>
@@ -3286,26 +3299,34 @@
           <a:p/>
           <a:p>
             <a:pPr>
-              <a:defRPr sz="1800"/>
-            </a:pPr>
-            <a:r>
-              <a:t>Express.js server with /api/health, /api/viz-specs, /api/analyze endpoints</a:t>
-            </a:r>
-          </a:p>
-          <a:p>
-            <a:pPr>
-              <a:defRPr sz="1800"/>
-            </a:pPr>
-            <a:r>
-              <a:t>Static SPA serving disparity charts and KPI cards</a:t>
-            </a:r>
-          </a:p>
-          <a:p>
-            <a:pPr>
-              <a:defRPr sz="1800"/>
-            </a:pPr>
-            <a:r>
-              <a:t>Implementation choice: Thin API layer over TypeScript statistical core, no duplicated logic</a:t>
+              <a:defRPr sz="1600"/>
+            </a:pPr>
+            <a:r>
+              <a:t>Policy researchers think in models, not APIs</a:t>
+            </a:r>
+          </a:p>
+          <a:p>
+            <a:pPr>
+              <a:defRPr sz="1600"/>
+            </a:pPr>
+            <a:r>
+              <a:t>The akashic.civics R package provides OLS, logistic regression, doubly-robust estimation, and disconfirmation batteries</a:t>
+            </a:r>
+          </a:p>
+          <a:p>
+            <a:pPr>
+              <a:defRPr sz="1600"/>
+            </a:pPr>
+            <a:r>
+              <a:t>R CMD check compliant, with vignettes</a:t>
+            </a:r>
+          </a:p>
+          <a:p>
+            <a:pPr>
+              <a:defRPr sz="1600"/>
+            </a:pPr>
+            <a:r>
+              <a:t>FOR JUSTICE: When academic researchers can run the same analysis, findings carry weight in scholarly and policy debates</a:t>
             </a:r>
           </a:p>
         </p:txBody>
@@ -3344,7 +3365,7 @@
           <a:lstStyle/>
           <a:p>
             <a:r>
-              <a:t>Extension System + Publishing (E21 &amp; E20)</a:t>
+              <a:t>E23: Streaming Analysis -- Justice in (Near) Real Time</a:t>
             </a:r>
           </a:p>
         </p:txBody>
@@ -3366,26 +3387,42 @@
           <a:p/>
           <a:p>
             <a:pPr>
-              <a:defRPr sz="1800"/>
-            </a:pPr>
-            <a:r>
-              <a:t>ExtensionRegistry discovers DataSource, Analysis, Export, Transformation plugins</a:t>
-            </a:r>
-          </a:p>
-          <a:p>
-            <a:pPr>
-              <a:defRPr sz="1800"/>
-            </a:pPr>
-            <a:r>
-              <a:t>publish_pipeline.js: 11-step release cycle from lint to npm/PyPI/R</a:t>
-            </a:r>
-          </a:p>
-          <a:p>
-            <a:pPr>
-              <a:defRPr sz="1800"/>
-            </a:pPr>
-            <a:r>
-              <a:t>Implementation choice: Plugins let communities add their own data sources without forking</a:t>
+              <a:defRPr sz="1600"/>
+            </a:pPr>
+            <a:r>
+              <a:t>Disparity moves fast</a:t>
+            </a:r>
+          </a:p>
+          <a:p>
+            <a:pPr>
+              <a:defRPr sz="1600"/>
+            </a:pPr>
+            <a:r>
+              <a:t>Policy changes, court closures, or surges in crime types can shift ratios dramatically</a:t>
+            </a:r>
+          </a:p>
+          <a:p>
+            <a:pPr>
+              <a:defRPr sz="1600"/>
+            </a:pPr>
+            <a:r>
+              <a:t>StreamProcessor reads JSONL in chunks, tracks group-level statistics, and fires alerts when disparity crosses thresholds</a:t>
+            </a:r>
+          </a:p>
+          <a:p>
+            <a:pPr>
+              <a:defRPr sz="1600"/>
+            </a:pPr>
+            <a:r>
+              <a:t>FOR DEMOCRACY: Real-time monitoring turns reactive analysis into proactive intervention</a:t>
+            </a:r>
+          </a:p>
+          <a:p>
+            <a:pPr>
+              <a:defRPr sz="1600"/>
+            </a:pPr>
+            <a:r>
+              <a:t>When the ratio jumps, advocates know to act</a:t>
             </a:r>
           </a:p>
         </p:txBody>
@@ -3424,7 +3461,7 @@
           <a:lstStyle/>
           <a:p>
             <a:r>
-              <a:t>Design Principles</a:t>
+              <a:t>E24: Web Dashboard UI -- Storytelling for Citizens</a:t>
             </a:r>
           </a:p>
         </p:txBody>
@@ -3446,34 +3483,34 @@
           <a:p/>
           <a:p>
             <a:pPr>
-              <a:defRPr sz="1800"/>
-            </a:pPr>
-            <a:r>
-              <a:t>Multi-language by design -- meet users where they are (TS, Python, R)</a:t>
-            </a:r>
-          </a:p>
-          <a:p>
-            <a:pPr>
-              <a:defRPr sz="1800"/>
-            </a:pPr>
-            <a:r>
-              <a:t>Statistical rigor first -- no headline numbers without confidence intervals and effect sizes</a:t>
-            </a:r>
-          </a:p>
-          <a:p>
-            <a:pPr>
-              <a:defRPr sz="1800"/>
-            </a:pPr>
-            <a:r>
-              <a:t>Local data, local control -- data never leaves the user's machine unless they choose to share it</a:t>
-            </a:r>
-          </a:p>
-          <a:p>
-            <a:pPr>
-              <a:defRPr sz="1800"/>
-            </a:pPr>
-            <a:r>
-              <a:t>Composable, not monolithic -- use the dashboard, CLI, or just the R package</a:t>
+              <a:defRPr sz="1600"/>
+            </a:pPr>
+            <a:r>
+              <a:t>Most users won't run code</a:t>
+            </a:r>
+          </a:p>
+          <a:p>
+            <a:pPr>
+              <a:defRPr sz="1600"/>
+            </a:pPr>
+            <a:r>
+              <a:t>An Express REST API (/api/health, /api/viz-specs, /api/analyze) powers a static single-page app</a:t>
+            </a:r>
+          </a:p>
+          <a:p>
+            <a:pPr>
+              <a:defRPr sz="1600"/>
+            </a:pPr>
+            <a:r>
+              <a:t>Shows disparity ratios, conviction rates, and sentence lengths</a:t>
+            </a:r>
+          </a:p>
+          <a:p>
+            <a:pPr>
+              <a:defRPr sz="1600"/>
+            </a:pPr>
+            <a:r>
+              <a:t>FOR JUSTICE: When disparities are visible on a dashboard in a community meeting, officials must confront them</a:t>
             </a:r>
           </a:p>
         </p:txBody>
@@ -3512,7 +3549,7 @@
           <a:lstStyle/>
           <a:p>
             <a:r>
-              <a:t>Why Doubly-Robust? Why Bayesian?</a:t>
+              <a:t>E25: Python Statistical Depth -- Scientific Rigor, Not Guesswork</a:t>
             </a:r>
           </a:p>
         </p:txBody>
@@ -3534,34 +3571,42 @@
           <a:p/>
           <a:p>
             <a:pPr>
-              <a:defRPr sz="1800"/>
-            </a:pPr>
-            <a:r>
-              <a:t>Simple rate comparisons -&gt; confounded by case mix</a:t>
-            </a:r>
-          </a:p>
-          <a:p>
-            <a:pPr>
-              <a:defRPr sz="1800"/>
-            </a:pPr>
-            <a:r>
-              <a:t>Doubly-robust -&gt; consistent if either propensity or outcome model is correct</a:t>
-            </a:r>
-          </a:p>
-          <a:p>
-            <a:pPr>
-              <a:defRPr sz="1800"/>
-            </a:pPr>
-            <a:r>
-              <a:t>Bayesian hierarchical -&gt; small jurisdictions get stable estimates through partial pooling</a:t>
-            </a:r>
-          </a:p>
-          <a:p>
-            <a:pPr>
-              <a:defRPr sz="1800"/>
-            </a:pPr>
-            <a:r>
-              <a:t>Why it matters for equity: A tiny rural county shouldn't get same weight as a city with 50,000 cases</a:t>
+              <a:defRPr sz="1600"/>
+            </a:pPr>
+            <a:r>
+              <a:t>Numbers must be right</a:t>
+            </a:r>
+          </a:p>
+          <a:p>
+            <a:pPr>
+              <a:defRPr sz="1600"/>
+            </a:pPr>
+            <a:r>
+              <a:t>Real NumPy/SciPy implementations of descriptive statistics, Z-tests, OLS, logistic regression, doubly-robust estimation</a:t>
+            </a:r>
+          </a:p>
+          <a:p>
+            <a:pPr>
+              <a:defRPr sz="1600"/>
+            </a:pPr>
+            <a:r>
+              <a:t>Disconfirmation batteries and jurisdiction comparison</a:t>
+            </a:r>
+          </a:p>
+          <a:p>
+            <a:pPr>
+              <a:defRPr sz="1600"/>
+            </a:pPr>
+            <a:r>
+              <a:t>Error handling with informative messages</a:t>
+            </a:r>
+          </a:p>
+          <a:p>
+            <a:pPr>
+              <a:defRPr sz="1600"/>
+            </a:pPr>
+            <a:r>
+              <a:t>FOR DEMOCRACY: Communities can trust their analysis withstands peer review, FOIA challenges, and expert scrutiny</a:t>
             </a:r>
           </a:p>
         </p:txBody>
@@ -3600,7 +3645,7 @@
           <a:lstStyle/>
           <a:p>
             <a:r>
-              <a:t>Why Stream, Why Alert?</a:t>
+              <a:t>A Concrete Democracy in Action</a:t>
             </a:r>
           </a:p>
         </p:txBody>
@@ -3622,34 +3667,66 @@
           <a:p/>
           <a:p>
             <a:pPr>
-              <a:defRPr sz="1800"/>
-            </a:pPr>
-            <a:r>
-              <a:t>Batch analysis answers 'what happened?'</a:t>
-            </a:r>
-          </a:p>
-          <a:p>
-            <a:pPr>
-              <a:defRPr sz="1800"/>
-            </a:pPr>
-            <a:r>
-              <a:t>Streaming answers 'is it happening right now?'</a:t>
-            </a:r>
-          </a:p>
-          <a:p>
-            <a:pPr>
-              <a:defRPr sz="1800"/>
-            </a:pPr>
-            <a:r>
-              <a:t>Alert thresholds -&gt; early warning for advocates and oversight bodies</a:t>
-            </a:r>
-          </a:p>
-          <a:p>
-            <a:pPr>
-              <a:defRPr sz="1800"/>
-            </a:pPr>
-            <a:r>
-              <a:t>Different between studying injustice and interrupting it</a:t>
+              <a:defRPr sz="1600"/>
+            </a:pPr>
+            <a:r>
+              <a:t>Scenario: Mid-sized county, 12,000 cases/year</a:t>
+            </a:r>
+          </a:p>
+          <a:p>
+            <a:pPr>
+              <a:defRPr sz="1600"/>
+            </a:pPr>
+            <a:r>
+              <a:t>Community group loads 3 years of data into Akashic Civics</a:t>
+            </a:r>
+          </a:p>
+          <a:p>
+            <a:pPr>
+              <a:defRPr sz="1600"/>
+            </a:pPr>
+            <a:r>
+              <a:t>Doubly-robust analysis: Black defendants convicted at 1.4x rate of White defendants (p&lt;0.01)</a:t>
+            </a:r>
+          </a:p>
+          <a:p>
+            <a:pPr>
+              <a:defRPr sz="1600"/>
+            </a:pPr>
+            <a:r>
+              <a:t>Streaming alert: ratio jumped from 1.2x to 1.6x after new DA took office</a:t>
+            </a:r>
+          </a:p>
+          <a:p>
+            <a:pPr>
+              <a:defRPr sz="1600"/>
+            </a:pPr>
+            <a:r>
+              <a:t>Group presents findings at public safety committee hearing</a:t>
+            </a:r>
+          </a:p>
+          <a:p>
+            <a:pPr>
+              <a:defRPr sz="1600"/>
+            </a:pPr>
+            <a:r>
+              <a:t>DA adopts new charging guidelines</a:t>
+            </a:r>
+          </a:p>
+          <a:p>
+            <a:pPr>
+              <a:defRPr sz="1600"/>
+            </a:pPr>
+            <a:r>
+              <a:t>Next quarter: disparity drops to 1.1x</a:t>
+            </a:r>
+          </a:p>
+          <a:p>
+            <a:pPr>
+              <a:defRPr sz="1600"/>
+            </a:pPr>
+            <a:r>
+              <a:t>KEY: Measurement enabled accountability; accountability drove policy change; policy change reduced disparity</a:t>
             </a:r>
           </a:p>
         </p:txBody>
@@ -3688,7 +3765,7 @@
           <a:lstStyle/>
           <a:p>
             <a:r>
-              <a:t>Civic Impact -- Decision Points to Local Leaders</a:t>
+              <a:t>Toward a More Just Democracy</a:t>
             </a:r>
           </a:p>
         </p:txBody>
@@ -3710,34 +3787,34 @@
           <a:p/>
           <a:p>
             <a:pPr>
-              <a:defRPr sz="1800"/>
-            </a:pPr>
-            <a:r>
-              <a:t>Charging -&gt; District Attorney measures conviction rate by demographic</a:t>
-            </a:r>
-          </a:p>
-          <a:p>
-            <a:pPr>
-              <a:defRPr sz="1800"/>
-            </a:pPr>
-            <a:r>
-              <a:t>Bail / Pretrial -&gt; Judge measures pretrial detention disparity</a:t>
-            </a:r>
-          </a:p>
-          <a:p>
-            <a:pPr>
-              <a:defRPr sz="1800"/>
-            </a:pPr>
-            <a:r>
-              <a:t>Sentencing -&gt; Judge measures sentence length disparity</a:t>
-            </a:r>
-          </a:p>
-          <a:p>
-            <a:pPr>
-              <a:defRPr sz="1800"/>
-            </a:pPr>
-            <a:r>
-              <a:t>Diversion -&gt; Prosecutor/Court measures disposition flow</a:t>
+              <a:defRPr sz="1600"/>
+            </a:pPr>
+            <a:r>
+              <a:t>Transparency: Disparity metrics no longer locked in prosecutors' spreadsheets</a:t>
+            </a:r>
+          </a:p>
+          <a:p>
+            <a:pPr>
+              <a:defRPr sz="1600"/>
+            </a:pPr>
+            <a:r>
+              <a:t>Participation: Community groups analyze the same data as officials</a:t>
+            </a:r>
+          </a:p>
+          <a:p>
+            <a:pPr>
+              <a:defRPr sz="1600"/>
+            </a:pPr>
+            <a:r>
+              <a:t>Accountability: Elected leaders evaluated on measurable outcomes</a:t>
+            </a:r>
+          </a:p>
+          <a:p>
+            <a:pPr>
+              <a:defRPr sz="1600"/>
+            </a:pPr>
+            <a:r>
+              <a:t>Reform Evaluation: Did the policy actually reduce disparity? We can tell.</a:t>
             </a:r>
           </a:p>
         </p:txBody>
@@ -3767,81 +3844,37 @@
             <a:spLocks noGrp="1"/>
           </p:cNvSpPr>
           <p:nvPr>
-            <p:ph type="title"/>
-          </p:nvPr>
-        </p:nvSpPr>
-        <p:spPr/>
-        <p:txBody>
-          <a:bodyPr/>
-          <a:lstStyle/>
-          <a:p>
-            <a:r>
-              <a:t>A Concrete Scenario</a:t>
-            </a:r>
-          </a:p>
-        </p:txBody>
-      </p:sp>
-      <p:sp>
-        <p:nvSpPr>
-          <p:cNvPr id="3" name="Content Placeholder 2"/>
-          <p:cNvSpPr>
-            <a:spLocks noGrp="1"/>
-          </p:cNvSpPr>
-          <p:nvPr>
-            <p:ph idx="1"/>
-          </p:nvPr>
-        </p:nvSpPr>
-        <p:spPr/>
-        <p:txBody>
-          <a:bodyPr/>
-          <a:lstStyle/>
-          <a:p/>
-          <a:p>
-            <a:pPr>
-              <a:defRPr sz="1800"/>
-            </a:pPr>
-            <a:r>
-              <a:t>Mid-sized county, 12,000 cases/year</a:t>
-            </a:r>
-          </a:p>
-          <a:p>
-            <a:pPr>
-              <a:defRPr sz="1800"/>
-            </a:pPr>
-            <a:r>
-              <a:t>Community loads 3 years of case data into Akashic Civics</a:t>
-            </a:r>
-          </a:p>
-          <a:p>
-            <a:pPr>
-              <a:defRPr sz="1800"/>
-            </a:pPr>
-            <a:r>
-              <a:t>Doubly-robust: Black defendants convicted at 1.4x rate of White defendants (p &lt; 0.01)</a:t>
-            </a:r>
-          </a:p>
-          <a:p>
-            <a:pPr>
-              <a:defRPr sz="1800"/>
-            </a:pPr>
-            <a:r>
-              <a:t>Streaming alert: disparity ratio rose from 1.2x to 1.6x after new DA took office</a:t>
-            </a:r>
-          </a:p>
-          <a:p>
-            <a:pPr>
-              <a:defRPr sz="1800"/>
-            </a:pPr>
-            <a:r>
-              <a:t>Community presents findings at hearing -&gt; DA adopts new charging guidelines</a:t>
-            </a:r>
-          </a:p>
-          <a:p>
-            <a:pPr>
-              <a:defRPr sz="1800"/>
-            </a:pPr>
-            <a:r>
-              <a:t>Next quarter: disparity drops to 1.1x</a:t>
+            <p:ph type="ctrTitle"/>
+          </p:nvPr>
+        </p:nvSpPr>
+        <p:spPr/>
+        <p:txBody>
+          <a:bodyPr/>
+          <a:lstStyle/>
+          <a:p>
+            <a:r>
+              <a:t>Thank You</a:t>
+            </a:r>
+          </a:p>
+        </p:txBody>
+      </p:sp>
+      <p:sp>
+        <p:nvSpPr>
+          <p:cNvPr id="3" name="Subtitle 2"/>
+          <p:cNvSpPr>
+            <a:spLocks noGrp="1"/>
+          </p:cNvSpPr>
+          <p:nvPr>
+            <p:ph type="subTitle" idx="1"/>
+          </p:nvPr>
+        </p:nvSpPr>
+        <p:spPr/>
+        <p:txBody>
+          <a:bodyPr/>
+          <a:lstStyle/>
+          <a:p>
+            <a:r>
+              <a:t>Questions &amp; Discussion</a:t>
             </a:r>
           </a:p>
         </p:txBody>
@@ -3880,7 +3913,7 @@
           <a:lstStyle/>
           <a:p>
             <a:r>
-              <a:t>Promoting Democracy</a:t>
+              <a:t>Questions &amp; Discussion</a:t>
             </a:r>
           </a:p>
         </p:txBody>
@@ -3902,130 +3935,26 @@
           <a:p/>
           <a:p>
             <a:pPr>
-              <a:defRPr sz="1800"/>
-            </a:pPr>
-            <a:r>
-              <a:t>Transparency: Disparity metrics are no longer locked in prosecutors' spreadsheets</a:t>
-            </a:r>
-          </a:p>
-          <a:p>
-            <a:pPr>
-              <a:defRPr sz="1800"/>
-            </a:pPr>
-            <a:r>
-              <a:t>Participation: Community groups can analyze the same data as officials</a:t>
-            </a:r>
-          </a:p>
-          <a:p>
-            <a:pPr>
-              <a:defRPr sz="1800"/>
-            </a:pPr>
-            <a:r>
-              <a:t>Accountability: Elected leaders can be evaluated on measurable outcomes</a:t>
-            </a:r>
-          </a:p>
-          <a:p>
-            <a:pPr>
-              <a:defRPr sz="1800"/>
-            </a:pPr>
-            <a:r>
-              <a:t>Reform evaluation: Did the new policy actually reduce disparity? We can tell.</a:t>
-            </a:r>
-          </a:p>
-        </p:txBody>
-      </p:sp>
-    </p:spTree>
-  </p:cSld>
-  <p:clrMapOvr>
-    <a:masterClrMapping/>
-  </p:clrMapOvr>
-</p:sld>
-</file>
-
-<file path=ppt/slides/slide19.xml><?xml version="1.0" encoding="utf-8"?>
-<p:sld xmlns:a="http://schemas.openxmlformats.org/drawingml/2006/main" xmlns:p="http://schemas.openxmlformats.org/presentationml/2006/main" xmlns:r="http://schemas.openxmlformats.org/officeDocument/2006/relationships">
-  <p:cSld>
-    <p:spTree>
-      <p:nvGrpSpPr>
-        <p:cNvPr id="1" name=""/>
-        <p:cNvGrpSpPr/>
-        <p:nvPr/>
-      </p:nvGrpSpPr>
-      <p:grpSpPr/>
-      <p:sp>
-        <p:nvSpPr>
-          <p:cNvPr id="2" name="Title 1"/>
-          <p:cNvSpPr>
-            <a:spLocks noGrp="1"/>
-          </p:cNvSpPr>
-          <p:nvPr>
-            <p:ph type="title"/>
-          </p:nvPr>
-        </p:nvSpPr>
-        <p:spPr/>
-        <p:txBody>
-          <a:bodyPr/>
-          <a:lstStyle/>
-          <a:p>
-            <a:r>
-              <a:t>Get Involved</a:t>
-            </a:r>
-          </a:p>
-        </p:txBody>
-      </p:sp>
-      <p:sp>
-        <p:nvSpPr>
-          <p:cNvPr id="3" name="Content Placeholder 2"/>
-          <p:cNvSpPr>
-            <a:spLocks noGrp="1"/>
-          </p:cNvSpPr>
-          <p:nvPr>
-            <p:ph idx="1"/>
-          </p:nvPr>
-        </p:nvSpPr>
-        <p:spPr/>
-        <p:txBody>
-          <a:bodyPr/>
-          <a:lstStyle/>
-          <a:p/>
-          <a:p>
-            <a:pPr>
-              <a:defRPr sz="1800"/>
-            </a:pPr>
-            <a:r>
-              <a:t>Install: npm install akashic-civics OR pip install akashic-civics-py OR R CMD INSTALL</a:t>
-            </a:r>
-          </a:p>
-          <a:p>
-            <a:pPr>
-              <a:defRPr sz="1800"/>
-            </a:pPr>
-            <a:r>
-              <a:t>Run the wizard: akashic wizard</a:t>
-            </a:r>
-          </a:p>
-          <a:p>
-            <a:pPr>
-              <a:defRPr sz="1800"/>
-            </a:pPr>
-            <a:r>
-              <a:t>Launch the dashboard: akashic dashboard</a:t>
-            </a:r>
-          </a:p>
-          <a:p>
-            <a:pPr>
-              <a:defRPr sz="1800"/>
-            </a:pPr>
-            <a:r>
-              <a:t>Contribute: extensions, data sources, visualizations, documentation</a:t>
-            </a:r>
-          </a:p>
-          <a:p>
-            <a:pPr>
-              <a:defRPr sz="1800"/>
-            </a:pPr>
-            <a:r>
-              <a:t>GitHub: github.com/elijah/akashic-civics</a:t>
+              <a:defRPr sz="1600"/>
+            </a:pPr>
+            <a:r>
+              <a:t>What local decisions most need measurement in your community?</a:t>
+            </a:r>
+          </a:p>
+          <a:p>
+            <a:pPr>
+              <a:defRPr sz="1600"/>
+            </a:pPr>
+            <a:r>
+              <a:t>Which data sources would you ship as extensions?</a:t>
+            </a:r>
+          </a:p>
+          <a:p>
+            <a:pPr>
+              <a:defRPr sz="1600"/>
+            </a:pPr>
+            <a:r>
+              <a:t>How can tools move from reporting injustice to changing it?</a:t>
             </a:r>
           </a:p>
         </p:txBody>
@@ -4064,7 +3993,7 @@
           <a:lstStyle/>
           <a:p>
             <a:r>
-              <a:t>The Civic Problem</a:t>
+              <a:t>The Civic Problem: Democracy Without Data</a:t>
             </a:r>
           </a:p>
         </p:txBody>
@@ -4086,178 +4015,42 @@
           <a:p/>
           <a:p>
             <a:pPr>
-              <a:defRPr sz="1800"/>
-            </a:pPr>
-            <a:r>
-              <a:t>Local criminal justice decisions shape lives -- but are rarely measured</a:t>
-            </a:r>
-          </a:p>
-          <a:p>
-            <a:pPr>
-              <a:defRPr sz="1800"/>
-            </a:pPr>
-            <a:r>
-              <a:t>Arrests, charges, convictions, and sentences happen at the local level</a:t>
-            </a:r>
-          </a:p>
-          <a:p>
-            <a:pPr>
-              <a:defRPr sz="1800"/>
-            </a:pPr>
-            <a:r>
-              <a:t>District attorneys, sheriffs, and judges wield enormous discretion</a:t>
-            </a:r>
-          </a:p>
-          <a:p>
-            <a:pPr>
-              <a:defRPr sz="1800"/>
-            </a:pPr>
-            <a:r>
-              <a:t>Disparity by race, income, and neighborhood is well-documented nationally -- but local data is fragmented</a:t>
-            </a:r>
-          </a:p>
-          <a:p>
-            <a:pPr>
-              <a:defRPr sz="1800"/>
-            </a:pPr>
-            <a:r>
-              <a:t>Without measurable baselines, communities cannot advocate for change or evaluate reform</a:t>
-            </a:r>
-          </a:p>
-        </p:txBody>
-      </p:sp>
-    </p:spTree>
-  </p:cSld>
-  <p:clrMapOvr>
-    <a:masterClrMapping/>
-  </p:clrMapOvr>
-</p:sld>
-</file>
-
-<file path=ppt/slides/slide20.xml><?xml version="1.0" encoding="utf-8"?>
-<p:sld xmlns:a="http://schemas.openxmlformats.org/drawingml/2006/main" xmlns:p="http://schemas.openxmlformats.org/presentationml/2006/main" xmlns:r="http://schemas.openxmlformats.org/officeDocument/2006/relationships">
-  <p:cSld>
-    <p:spTree>
-      <p:nvGrpSpPr>
-        <p:cNvPr id="1" name=""/>
-        <p:cNvGrpSpPr/>
-        <p:nvPr/>
-      </p:nvGrpSpPr>
-      <p:grpSpPr/>
-      <p:sp>
-        <p:nvSpPr>
-          <p:cNvPr id="2" name="Title 1"/>
-          <p:cNvSpPr>
-            <a:spLocks noGrp="1"/>
-          </p:cNvSpPr>
-          <p:nvPr>
-            <p:ph type="ctrTitle"/>
-          </p:nvPr>
-        </p:nvSpPr>
-        <p:spPr/>
-        <p:txBody>
-          <a:bodyPr/>
-          <a:lstStyle/>
-          <a:p>
-            <a:r>
-              <a:t>Thank You</a:t>
-            </a:r>
-          </a:p>
-        </p:txBody>
-      </p:sp>
-      <p:sp>
-        <p:nvSpPr>
-          <p:cNvPr id="3" name="Subtitle 2"/>
-          <p:cNvSpPr>
-            <a:spLocks noGrp="1"/>
-          </p:cNvSpPr>
-          <p:nvPr>
-            <p:ph type="subTitle" idx="1"/>
-          </p:nvPr>
-        </p:nvSpPr>
-        <p:spPr/>
-        <p:txBody>
-          <a:bodyPr/>
-          <a:lstStyle/>
-          <a:p>
-            <a:r>
-              <a:t>Questions &amp; Discussion</a:t>
-            </a:r>
-          </a:p>
-        </p:txBody>
-      </p:sp>
-    </p:spTree>
-  </p:cSld>
-  <p:clrMapOvr>
-    <a:masterClrMapping/>
-  </p:clrMapOvr>
-</p:sld>
-</file>
-
-<file path=ppt/slides/slide21.xml><?xml version="1.0" encoding="utf-8"?>
-<p:sld xmlns:a="http://schemas.openxmlformats.org/drawingml/2006/main" xmlns:p="http://schemas.openxmlformats.org/presentationml/2006/main" xmlns:r="http://schemas.openxmlformats.org/officeDocument/2006/relationships">
-  <p:cSld>
-    <p:spTree>
-      <p:nvGrpSpPr>
-        <p:cNvPr id="1" name=""/>
-        <p:cNvGrpSpPr/>
-        <p:nvPr/>
-      </p:nvGrpSpPr>
-      <p:grpSpPr/>
-      <p:sp>
-        <p:nvSpPr>
-          <p:cNvPr id="2" name="Title 1"/>
-          <p:cNvSpPr>
-            <a:spLocks noGrp="1"/>
-          </p:cNvSpPr>
-          <p:nvPr>
-            <p:ph type="title"/>
-          </p:nvPr>
-        </p:nvSpPr>
-        <p:spPr/>
-        <p:txBody>
-          <a:bodyPr/>
-          <a:lstStyle/>
-          <a:p/>
-        </p:txBody>
-      </p:sp>
-      <p:sp>
-        <p:nvSpPr>
-          <p:cNvPr id="3" name="Content Placeholder 2"/>
-          <p:cNvSpPr>
-            <a:spLocks noGrp="1"/>
-          </p:cNvSpPr>
-          <p:nvPr>
-            <p:ph idx="1"/>
-          </p:nvPr>
-        </p:nvSpPr>
-        <p:spPr/>
-        <p:txBody>
-          <a:bodyPr/>
-          <a:lstStyle/>
-          <a:p/>
-          <a:p>
-            <a:pPr>
-              <a:defRPr sz="1800"/>
-            </a:pPr>
-            <a:r>
-              <a:t>How could your community use disparity data?</a:t>
-            </a:r>
-          </a:p>
-          <a:p>
-            <a:pPr>
-              <a:defRPr sz="1800"/>
-            </a:pPr>
-            <a:r>
-              <a:t>What local decisions most need measurement?</a:t>
-            </a:r>
-          </a:p>
-          <a:p>
-            <a:pPr>
-              <a:defRPr sz="1800"/>
-            </a:pPr>
-            <a:r>
-              <a:t>What data sources should we integrate next?</a:t>
+              <a:defRPr sz="1600"/>
+            </a:pPr>
+            <a:r>
+              <a:t>Local criminal justice decisions shape lives -- but are invisible</a:t>
+            </a:r>
+          </a:p>
+          <a:p>
+            <a:pPr>
+              <a:defRPr sz="1600"/>
+            </a:pPr>
+            <a:r>
+              <a:t>District attorneys, sheriffs, and judges exercise enormous discretion over arrests, charges, bonds, sentences, and parole</a:t>
+            </a:r>
+          </a:p>
+          <a:p>
+            <a:pPr>
+              <a:defRPr sz="1600"/>
+            </a:pPr>
+            <a:r>
+              <a:t>Race, income, and neighborhood predict outcomes more reliably than the law should</a:t>
+            </a:r>
+          </a:p>
+          <a:p>
+            <a:pPr>
+              <a:defRPr sz="1600"/>
+            </a:pPr>
+            <a:r>
+              <a:t>Yet without measurement, communities cannot name it, cannot challenge it, cannot change it</a:t>
+            </a:r>
+          </a:p>
+          <a:p>
+            <a:pPr>
+              <a:defRPr sz="1600"/>
+            </a:pPr>
+            <a:r>
+              <a:t>WHY JUSTICE REQUIRES MEASUREMENT: Transparency is the minimum condition for accountability in a democracy</a:t>
             </a:r>
           </a:p>
         </p:txBody>
@@ -4296,7 +4089,7 @@
           <a:lstStyle/>
           <a:p>
             <a:r>
-              <a:t>What Akashic Civics Does</a:t>
+              <a:t>What We're Building: Tools for Community Power</a:t>
             </a:r>
           </a:p>
         </p:txBody>
@@ -4318,42 +4111,34 @@
           <a:p/>
           <a:p>
             <a:pPr>
-              <a:defRPr sz="1800"/>
-            </a:pPr>
-            <a:r>
-              <a:t>Ingest local case data from any jurisdiction</a:t>
-            </a:r>
-          </a:p>
-          <a:p>
-            <a:pPr>
-              <a:defRPr sz="1800"/>
-            </a:pPr>
-            <a:r>
-              <a:t>Run statistical tests (Z-tests, regression, causal inference)</a:t>
-            </a:r>
-          </a:p>
-          <a:p>
-            <a:pPr>
-              <a:defRPr sz="1800"/>
-            </a:pPr>
-            <a:r>
-              <a:t>Track disparities over time with streaming analysis</a:t>
-            </a:r>
-          </a:p>
-          <a:p>
-            <a:pPr>
-              <a:defRPr sz="1800"/>
-            </a:pPr>
-            <a:r>
-              <a:t>Export reports for advocacy, journalism, and policy</a:t>
-            </a:r>
-          </a:p>
-          <a:p>
-            <a:pPr>
-              <a:defRPr sz="1800"/>
-            </a:pPr>
-            <a:r>
-              <a:t>Available in TypeScript, Python, and R</a:t>
+              <a:defRPr sz="1600"/>
+            </a:pPr>
+            <a:r>
+              <a:t>Akashic Civics is open-source infrastructure that helps communities turn fragmented local data into actionable insight</a:t>
+            </a:r>
+          </a:p>
+          <a:p>
+            <a:pPr>
+              <a:defRPr sz="1600"/>
+            </a:pPr>
+            <a:r>
+              <a:t>We combine statistical rigor with civic accessibility: TypeScript -&gt; Python -&gt; R</a:t>
+            </a:r>
+          </a:p>
+          <a:p>
+            <a:pPr>
+              <a:defRPr sz="1600"/>
+            </a:pPr>
+            <a:r>
+              <a:t>Modular extensions and dashboards designed for journalists, researchers, and activists</a:t>
+            </a:r>
+          </a:p>
+          <a:p>
+            <a:pPr>
+              <a:defRPr sz="1600"/>
+            </a:pPr>
+            <a:r>
+              <a:t>THE VISION: Data belongs to the community, not to the prosecutor</a:t>
             </a:r>
           </a:p>
         </p:txBody>
@@ -4392,7 +4177,7 @@
           <a:lstStyle/>
           <a:p>
             <a:r>
-              <a:t>The Enhancement Roadmap (E16-E25)</a:t>
+              <a:t>Design Principles</a:t>
             </a:r>
           </a:p>
         </p:txBody>
@@ -4414,82 +4199,34 @@
           <a:p/>
           <a:p>
             <a:pPr>
-              <a:defRPr sz="1800"/>
-            </a:pPr>
-            <a:r>
-              <a:t>E16: Data integration (FBI UCR, BJS)</a:t>
-            </a:r>
-          </a:p>
-          <a:p>
-            <a:pPr>
-              <a:defRPr sz="1800"/>
-            </a:pPr>
-            <a:r>
-              <a:t>E17: Advanced analytics (doubly-robust, Bayesian)</a:t>
-            </a:r>
-          </a:p>
-          <a:p>
-            <a:pPr>
-              <a:defRPr sz="1800"/>
-            </a:pPr>
-            <a:r>
-              <a:t>E18: Interactive CLI analysis wizard</a:t>
-            </a:r>
-          </a:p>
-          <a:p>
-            <a:pPr>
-              <a:defRPr sz="1800"/>
-            </a:pPr>
-            <a:r>
-              <a:t>E19: Jupyter Notebook interface</a:t>
-            </a:r>
-          </a:p>
-          <a:p>
-            <a:pPr>
-              <a:defRPr sz="1800"/>
-            </a:pPr>
-            <a:r>
-              <a:t>E20: Publishing/release pipeline</a:t>
-            </a:r>
-          </a:p>
-          <a:p>
-            <a:pPr>
-              <a:defRPr sz="1800"/>
-            </a:pPr>
-            <a:r>
-              <a:t>E21: Extension system (plugins)</a:t>
-            </a:r>
-          </a:p>
-          <a:p>
-            <a:pPr>
-              <a:defRPr sz="1800"/>
-            </a:pPr>
-            <a:r>
-              <a:t>E22: R package (regression, causal, comparison)</a:t>
-            </a:r>
-          </a:p>
-          <a:p>
-            <a:pPr>
-              <a:defRPr sz="1800"/>
-            </a:pPr>
-            <a:r>
-              <a:t>E23: Streaming analysis with disparity alerts</a:t>
-            </a:r>
-          </a:p>
-          <a:p>
-            <a:pPr>
-              <a:defRPr sz="1800"/>
-            </a:pPr>
-            <a:r>
-              <a:t>E24: Web dashboard UI + Express API</a:t>
-            </a:r>
-          </a:p>
-          <a:p>
-            <a:pPr>
-              <a:defRPr sz="1800"/>
-            </a:pPr>
-            <a:r>
-              <a:t>E25: Python statistical depth (NumPy/SciPy)</a:t>
+              <a:defRPr sz="1600"/>
+            </a:pPr>
+            <a:r>
+              <a:t>Multi-language by design -- Meet users where they are (policy researchers use R, data scientists use Python, civic tech uses TypeScript)</a:t>
+            </a:r>
+          </a:p>
+          <a:p>
+            <a:pPr>
+              <a:defRPr sz="1600"/>
+            </a:pPr>
+            <a:r>
+              <a:t>Statistical rigor first -- No headline numbers without confidence intervals and causal interpretation</a:t>
+            </a:r>
+          </a:p>
+          <a:p>
+            <a:pPr>
+              <a:defRPr sz="1600"/>
+            </a:pPr>
+            <a:r>
+              <a:t>Composable, not monolithic -- Use the dashboard, the CLI, or just the R package</a:t>
+            </a:r>
+          </a:p>
+          <a:p>
+            <a:pPr>
+              <a:defRPr sz="1600"/>
+            </a:pPr>
+            <a:r>
+              <a:t>WHY THIS MATTERS: Tools must fit into existing practices, not reinvent them</a:t>
             </a:r>
           </a:p>
         </p:txBody>
@@ -4528,7 +4265,7 @@
           <a:lstStyle/>
           <a:p>
             <a:r>
-              <a:t>Data Integration (E16)</a:t>
+              <a:t>E16: Data Integration -- The Foundation of Everything</a:t>
             </a:r>
           </a:p>
         </p:txBody>
@@ -4550,34 +4287,34 @@
           <a:p/>
           <a:p>
             <a:pPr>
-              <a:defRPr sz="1800"/>
-            </a:pPr>
-            <a:r>
-              <a:t>Pluggable DataSource interface</a:t>
-            </a:r>
-          </a:p>
-          <a:p>
-            <a:pPr>
-              <a:defRPr sz="1800"/>
-            </a:pPr>
-            <a:r>
-              <a:t>FBIUCRSource and BJSSource implementations</a:t>
-            </a:r>
-          </a:p>
-          <a:p>
-            <a:pPr>
-              <a:defRPr sz="1800"/>
-            </a:pPr>
-            <a:r>
-              <a:t>DataPipeline normalizes heterogeneous inputs into a common schema</a:t>
-            </a:r>
-          </a:p>
-          <a:p>
-            <a:pPr>
-              <a:defRPr sz="1800"/>
-            </a:pPr>
-            <a:r>
-              <a:t>Implementation choice: We normalized upstream rather than asking users to clean data</a:t>
+              <a:defRPr sz="1600"/>
+            </a:pPr>
+            <a:r>
+              <a:t>Data hides in silos. FBI UCR, BJS, and local court systems store 90% of what we need -- but in incompatible formats</a:t>
+            </a:r>
+          </a:p>
+          <a:p>
+            <a:pPr>
+              <a:defRPr sz="1600"/>
+            </a:pPr>
+            <a:r>
+              <a:t>Pluggable DataSource interfaces and a DataPipeline that normalizes to a common schema make analysis possible</a:t>
+            </a:r>
+          </a:p>
+          <a:p>
+            <a:pPr>
+              <a:defRPr sz="1600"/>
+            </a:pPr>
+            <a:r>
+              <a:t>9 tests ensure reliability across data sources</a:t>
+            </a:r>
+          </a:p>
+          <a:p>
+            <a:pPr>
+              <a:defRPr sz="1600"/>
+            </a:pPr>
+            <a:r>
+              <a:t>FOR DEMOCRACY: If data stays trapped in silos, communities stay powerless</a:t>
             </a:r>
           </a:p>
         </p:txBody>
@@ -4616,7 +4353,7 @@
           <a:lstStyle/>
           <a:p>
             <a:r>
-              <a:t>Advanced Analytics (E17)</a:t>
+              <a:t>E17: Advanced Analytics -- Causal, Not Just Correlational</a:t>
             </a:r>
           </a:p>
         </p:txBody>
@@ -4638,26 +4375,42 @@
           <a:p/>
           <a:p>
             <a:pPr>
-              <a:defRPr sz="1800"/>
-            </a:pPr>
-            <a:r>
-              <a:t>DoublyRobustEstimator -- combines propensity scores with outcome regression</a:t>
-            </a:r>
-          </a:p>
-          <a:p>
-            <a:pPr>
-              <a:defRPr sz="1800"/>
-            </a:pPr>
-            <a:r>
-              <a:t>BayesianHierarchicalModel -- partial pooling across jurisdictions</a:t>
-            </a:r>
-          </a:p>
-          <a:p>
-            <a:pPr>
-              <a:defRPr sz="1800"/>
-            </a:pPr>
-            <a:r>
-              <a:t>Implementation choice: Doubly-robust methods protect against model misspecification</a:t>
+              <a:defRPr sz="1600"/>
+            </a:pPr>
+            <a:r>
+              <a:t>Rates lie. A 1.4x conviction rate disparity might mean bias -- or just different crimes</a:t>
+            </a:r>
+          </a:p>
+          <a:p>
+            <a:pPr>
+              <a:defRPr sz="1600"/>
+            </a:pPr>
+            <a:r>
+              <a:t>DoublyRobustEstimator protects against model misspecification</a:t>
+            </a:r>
+          </a:p>
+          <a:p>
+            <a:pPr>
+              <a:defRPr sz="1600"/>
+            </a:pPr>
+            <a:r>
+              <a:t>BayesianHierarchicalModel stabilizes estimates in small jurisdictions</a:t>
+            </a:r>
+          </a:p>
+          <a:p>
+            <a:pPr>
+              <a:defRPr sz="1600"/>
+            </a:pPr>
+            <a:r>
+              <a:t>FOR JUSTICE: Causal methods answer 'Did this policy cause disparity?' not 'Are they correlated?'</a:t>
+            </a:r>
+          </a:p>
+          <a:p>
+            <a:pPr>
+              <a:defRPr sz="1600"/>
+            </a:pPr>
+            <a:r>
+              <a:t>This is how we move from observation to evidence-based reform</a:t>
             </a:r>
           </a:p>
         </p:txBody>
@@ -4696,7 +4449,7 @@
           <a:lstStyle/>
           <a:p>
             <a:r>
-              <a:t>Interactive CLI Wizard (E18)</a:t>
+              <a:t>E18: Interactive CLI Wizard -- Tools for Everyone</a:t>
             </a:r>
           </a:p>
         </p:txBody>
@@ -4718,26 +4471,42 @@
           <a:p/>
           <a:p>
             <a:pPr>
-              <a:defRPr sz="1800"/>
-            </a:pPr>
-            <a:r>
-              <a:t>5-step guided analysis for non-programmers</a:t>
-            </a:r>
-          </a:p>
-          <a:p>
-            <a:pPr>
-              <a:defRPr sz="1800"/>
-            </a:pPr>
-            <a:r>
-              <a:t>Select data source, choose jurisdiction, select analysis type, configure parameters, execute and export</a:t>
-            </a:r>
-          </a:p>
-          <a:p>
-            <a:pPr>
-              <a:defRPr sz="1800"/>
-            </a:pPr>
-            <a:r>
-              <a:t>Implementation choice: A wizard rather than raw commands</a:t>
+              <a:defRPr sz="1600"/>
+            </a:pPr>
+            <a:r>
+              <a:t>No PhD required</a:t>
+            </a:r>
+          </a:p>
+          <a:p>
+            <a:pPr>
+              <a:defRPr sz="1600"/>
+            </a:pPr>
+            <a:r>
+              <a:t>Non-programmers can load data, choose Jurisdiction, select analysis type, and get results in five steps</a:t>
+            </a:r>
+          </a:p>
+          <a:p>
+            <a:pPr>
+              <a:defRPr sz="1600"/>
+            </a:pPr>
+            <a:r>
+              <a:t>The wizard abstracts technical complexity while preserving methodological choices</a:t>
+            </a:r>
+          </a:p>
+          <a:p>
+            <a:pPr>
+              <a:defRPr sz="1600"/>
+            </a:pPr>
+            <a:r>
+              <a:t>FOR DEMOCRACY: When tools are usable, power diffuses</a:t>
+            </a:r>
+          </a:p>
+          <a:p>
+            <a:pPr>
+              <a:defRPr sz="1600"/>
+            </a:pPr>
+            <a:r>
+              <a:t>A civic organizer, not a statistician, can make the case to their DA</a:t>
             </a:r>
           </a:p>
         </p:txBody>
@@ -4776,7 +4545,7 @@
           <a:lstStyle/>
           <a:p>
             <a:r>
-              <a:t>Jupyter + Python (E19 &amp; E25)</a:t>
+              <a:t>E19: Jupyter Notebook Interface -- The Analyst's Playground</a:t>
             </a:r>
           </a:p>
         </p:txBody>
@@ -4798,26 +4567,34 @@
           <a:p/>
           <a:p>
             <a:pPr>
-              <a:defRPr sz="1800"/>
-            </a:pPr>
-            <a:r>
-              <a:t>IPython magics and NotebookGenerator with comparison templates</a:t>
-            </a:r>
-          </a:p>
-          <a:p>
-            <a:pPr>
-              <a:defRPr sz="1800"/>
-            </a:pPr>
-            <a:r>
-              <a:t>stats.py: descriptive stats, Z-tests, OLS, logistic regression, doubly-robust, disconfirmation, jurisdiction comparison</a:t>
-            </a:r>
-          </a:p>
-          <a:p>
-            <a:pPr>
-              <a:defRPr sz="1800"/>
-            </a:pPr>
-            <a:r>
-              <a:t>Implementation choice: Python wrappers try in-process NumPy/SciPy first, then fall back to CLI</a:t>
+              <a:defRPr sz="1600"/>
+            </a:pPr>
+            <a:r>
+              <a:t>Python users want magic, not CLI flags</a:t>
+            </a:r>
+          </a:p>
+          <a:p>
+            <a:pPr>
+              <a:defRPr sz="1600"/>
+            </a:pPr>
+            <a:r>
+              <a:t>IPython magics, rendered report templates, and direct NumPy/SciPy integration</a:t>
+            </a:r>
+          </a:p>
+          <a:p>
+            <a:pPr>
+              <a:defRPr sz="1600"/>
+            </a:pPr>
+            <a:r>
+              <a:t>Analysts can prototype, explore, and build public-facing narratives</a:t>
+            </a:r>
+          </a:p>
+          <a:p>
+            <a:pPr>
+              <a:defRPr sz="1600"/>
+            </a:pPr>
+            <a:r>
+              <a:t>FOR JUSTICE: When research is reproducible in a notebook, findings become shareable across coalitions</a:t>
             </a:r>
           </a:p>
         </p:txBody>
@@ -4856,7 +4633,7 @@
           <a:lstStyle/>
           <a:p>
             <a:r>
-              <a:t>R Package (E22)</a:t>
+              <a:t>E20: Publishing Pipeline -- Open Source Cannot Collapse</a:t>
             </a:r>
           </a:p>
         </p:txBody>
@@ -4878,26 +4655,34 @@
           <a:p/>
           <a:p>
             <a:pPr>
-              <a:defRPr sz="1800"/>
-            </a:pPr>
-            <a:r>
-              <a:t>CRAN-style package with descriptive stats, Z-tests, OLS/logistic regression</a:t>
-            </a:r>
-          </a:p>
-          <a:p>
-            <a:pPr>
-              <a:defRPr sz="1800"/>
-            </a:pPr>
-            <a:r>
-              <a:t>Doubly-robust causal estimation, disconfirmation battery, multi-jurisdiction comparison</a:t>
-            </a:r>
-          </a:p>
-          <a:p>
-            <a:pPr>
-              <a:defRPr sz="1800"/>
-            </a:pPr>
-            <a:r>
-              <a:t>Implementation choice: R is the lingua franca of public policy and criminology</a:t>
+              <a:defRPr sz="1600"/>
+            </a:pPr>
+            <a:r>
+              <a:t>Open-source projects die</a:t>
+            </a:r>
+          </a:p>
+          <a:p>
+            <a:pPr>
+              <a:defRPr sz="1600"/>
+            </a:pPr>
+            <a:r>
+              <a:t>An 11-step release pipeline (npm publish, pip install, R CMD INSTALL, docker push, automated testing, changelogs) keeps code current and trustworthy</a:t>
+            </a:r>
+          </a:p>
+          <a:p>
+            <a:pPr>
+              <a:defRPr sz="1600"/>
+            </a:pPr>
+            <a:r>
+              <a:t>FOR DEMOCRACY: Sustainability ensures tools survive grant cycles and volunteer turnover</a:t>
+            </a:r>
+          </a:p>
+          <a:p>
+            <a:pPr>
+              <a:defRPr sz="1600"/>
+            </a:pPr>
+            <a:r>
+              <a:t>Code must be a public good, not a one-person effort</a:t>
             </a:r>
           </a:p>
         </p:txBody>

</xml_diff>